<commit_message>
Reorganize Python course materials
</commit_message>
<xml_diff>
--- a/AI_tools/Claude/claude_code/1_setup.pptx
+++ b/AI_tools/Claude/claude_code/1_setup.pptx
@@ -5,10 +5,10 @@
     <p:sldMasterId id="2147483648" r:id="rId1"/>
   </p:sldMasterIdLst>
   <p:notesMasterIdLst>
-    <p:notesMasterId r:id="rId12"/>
+    <p:notesMasterId r:id="rId13"/>
   </p:notesMasterIdLst>
   <p:handoutMasterIdLst>
-    <p:handoutMasterId r:id="rId13"/>
+    <p:handoutMasterId r:id="rId14"/>
   </p:handoutMasterIdLst>
   <p:sldIdLst>
     <p:sldId id="257" r:id="rId2"/>
@@ -20,7 +20,8 @@
     <p:sldId id="279" r:id="rId8"/>
     <p:sldId id="276" r:id="rId9"/>
     <p:sldId id="280" r:id="rId10"/>
-    <p:sldId id="275" r:id="rId11"/>
+    <p:sldId id="284" r:id="rId11"/>
+    <p:sldId id="275" r:id="rId12"/>
   </p:sldIdLst>
   <p:sldSz cx="12192000" cy="6858000"/>
   <p:notesSz cx="6858000" cy="9144000"/>
@@ -224,7 +225,7 @@
           <a:p>
             <a:fld id="{7BAEECA8-D063-486F-AE31-5020270C1449}" type="datetimeFigureOut">
               <a:rPr lang="en-US" smtClean="0"/>
-              <a:t>8/10/2026</a:t>
+              <a:t>8/20/2026</a:t>
             </a:fld>
             <a:endParaRPr lang="en-US"/>
           </a:p>
@@ -875,6 +876,90 @@
 </inkml:ink>
 </file>
 
+<file path=ppt/ink/ink26.xml><?xml version="1.0" encoding="utf-8"?>
+<inkml:ink xmlns:inkml="http://www.w3.org/2003/InkML">
+  <inkml:definitions>
+    <inkml:context xml:id="ctx0">
+      <inkml:inkSource xml:id="inkSrc0">
+        <inkml:traceFormat>
+          <inkml:channel name="X" type="integer" min="-2.14748E9" max="2.14748E9" units="cm"/>
+          <inkml:channel name="Y" type="integer" min="-2.14748E9" max="2.14748E9" units="cm"/>
+          <inkml:channel name="F" type="integer" max="32767" units="dev"/>
+        </inkml:traceFormat>
+        <inkml:channelProperties>
+          <inkml:channelProperty channel="X" name="resolution" value="1000" units="1/cm"/>
+          <inkml:channelProperty channel="Y" name="resolution" value="1000" units="1/cm"/>
+          <inkml:channelProperty channel="F" name="resolution" value="0" units="1/dev"/>
+        </inkml:channelProperties>
+      </inkml:inkSource>
+      <inkml:timestamp xml:id="ts0" timeString="2026-08-20T12:39:52.002"/>
+    </inkml:context>
+    <inkml:brush xml:id="br0">
+      <inkml:brushProperty name="width" value="0.1" units="cm"/>
+      <inkml:brushProperty name="height" value="0.1" units="cm"/>
+      <inkml:brushProperty name="color" value="#FFC114"/>
+    </inkml:brush>
+  </inkml:definitions>
+  <inkml:trace contextRef="#ctx0" brushRef="#br0">1 889 24575,'0'0'0,"0"-1"0,1 1 0,-1 0 0,1 0 0,-1-1 0,1 1 0,-1 0 0,1 0 0,-1 0 0,1 0 0,-1 0 0,1-1 0,-1 1 0,1 0 0,-1 0 0,1 0 0,-1 0 0,1 0 0,-1 1 0,1-1 0,-1 0 0,1 0 0,-1 0 0,1 0 0,-1 1 0,1-1 0,-1 0 0,0 0 0,1 1 0,-1-1 0,1 0 0,-1 1 0,0-1 0,1 0 0,-1 1 0,0-1 0,1 0 0,-1 1 0,1 0 0,21 16 0,2 8 0,18 13 0,-39-36 0,-1-1 0,0 0 0,1 1 0,-1-1 0,0 0 0,1-1 0,-1 1 0,1 0 0,-1-1 0,1 1 0,0-1 0,-1 0 0,1 0 0,-1 0 0,1 0 0,0 0 0,-1-1 0,1 1 0,3-2 0,3-2 0,1 0 0,-1-1 0,0 0 0,0 0 0,0-1 0,0 0 0,13-14 0,52-61 0,-48 50 0,36-41 0,15-18 0,3 3 0,94-78 0,7 26 40,96-84-1445,-238 185-5421</inkml:trace>
+</inkml:ink>
+</file>
+
+<file path=ppt/ink/ink27.xml><?xml version="1.0" encoding="utf-8"?>
+<inkml:ink xmlns:inkml="http://www.w3.org/2003/InkML">
+  <inkml:definitions>
+    <inkml:context xml:id="ctx0">
+      <inkml:inkSource xml:id="inkSrc0">
+        <inkml:traceFormat>
+          <inkml:channel name="X" type="integer" min="-2.14748E9" max="2.14748E9" units="cm"/>
+          <inkml:channel name="Y" type="integer" min="-2.14748E9" max="2.14748E9" units="cm"/>
+          <inkml:channel name="F" type="integer" max="32767" units="dev"/>
+        </inkml:traceFormat>
+        <inkml:channelProperties>
+          <inkml:channelProperty channel="X" name="resolution" value="1000" units="1/cm"/>
+          <inkml:channelProperty channel="Y" name="resolution" value="1000" units="1/cm"/>
+          <inkml:channelProperty channel="F" name="resolution" value="0" units="1/dev"/>
+        </inkml:channelProperties>
+      </inkml:inkSource>
+      <inkml:timestamp xml:id="ts0" timeString="2026-08-20T12:39:54.524"/>
+    </inkml:context>
+    <inkml:brush xml:id="br0">
+      <inkml:brushProperty name="width" value="0.1" units="cm"/>
+      <inkml:brushProperty name="height" value="0.1" units="cm"/>
+      <inkml:brushProperty name="color" value="#FFC114"/>
+    </inkml:brush>
+  </inkml:definitions>
+  <inkml:trace contextRef="#ctx0" brushRef="#br0">0 463 24575,'0'0'0,"1"0"0,-1 0 0,1 1 0,0-1 0,-1 0 0,1 0 0,-1 0 0,1 0 0,-1 0 0,1 1 0,-1-1 0,1 0 0,-1 0 0,1 1 0,-1-1 0,1 0 0,-1 1 0,1-1 0,-1 1 0,1-1 0,-1 1 0,0-1 0,1 1 0,-1-1 0,0 1 0,0-1 0,1 1 0,109 162 0,-72-103 0,54 66 0,-90-122 0,0-1 0,0 0 0,1 0 0,-1 0 0,1 0 0,0-1 0,-1 1 0,1-1 0,0 0 0,1 1 0,-1-1 0,0-1 0,1 1 0,-1 0 0,1-1 0,-1 0 0,1 0 0,0 0 0,-1 0 0,1 0 0,0-1 0,0 0 0,0 0 0,0 0 0,-1 0 0,1 0 0,0-1 0,0 0 0,-1 1 0,7-4 0,19-9 0,0-1 0,-1-2 0,0 0 0,40-34 0,-31 23 0,636-443 3,-401 282-1371,-180 124-5458</inkml:trace>
+</inkml:ink>
+</file>
+
+<file path=ppt/ink/ink28.xml><?xml version="1.0" encoding="utf-8"?>
+<inkml:ink xmlns:inkml="http://www.w3.org/2003/InkML">
+  <inkml:definitions>
+    <inkml:context xml:id="ctx0">
+      <inkml:inkSource xml:id="inkSrc0">
+        <inkml:traceFormat>
+          <inkml:channel name="X" type="integer" min="-2.14748E9" max="2.14748E9" units="cm"/>
+          <inkml:channel name="Y" type="integer" min="-2.14748E9" max="2.14748E9" units="cm"/>
+          <inkml:channel name="F" type="integer" max="32767" units="dev"/>
+        </inkml:traceFormat>
+        <inkml:channelProperties>
+          <inkml:channelProperty channel="X" name="resolution" value="1000" units="1/cm"/>
+          <inkml:channelProperty channel="Y" name="resolution" value="1000" units="1/cm"/>
+          <inkml:channelProperty channel="F" name="resolution" value="0" units="1/dev"/>
+        </inkml:channelProperties>
+      </inkml:inkSource>
+      <inkml:timestamp xml:id="ts0" timeString="2026-08-20T12:39:57.253"/>
+    </inkml:context>
+    <inkml:brush xml:id="br0">
+      <inkml:brushProperty name="width" value="0.1" units="cm"/>
+      <inkml:brushProperty name="height" value="0.1" units="cm"/>
+      <inkml:brushProperty name="color" value="#FFC114"/>
+    </inkml:brush>
+  </inkml:definitions>
+  <inkml:trace contextRef="#ctx0" brushRef="#br0">940 1 24575,'-20'1'0,"1"1"0,0 1 0,0 1 0,-22 7 0,-16 3 0,-98 18 0,-154 55 0,292-81 0,-1 1 0,1 1 0,0 0 0,1 1 0,0 1 0,0 1 0,1 0 0,1 1 0,0 1 0,0 0 0,1 0 0,1 2 0,1 0 0,0 0 0,0 1 0,-13 29 0,16-29 0,0 0 0,1 0 0,1 1 0,-7 32 0,12-42 0,0 1 0,1-1 0,0 0 0,0 1 0,1-1 0,-1 0 0,2 1 0,-1-1 0,1 0 0,0 0 0,1 0 0,0 0 0,0 0 0,5 8 0,4 5 0,1-1 0,1 0 0,1-1 0,1 0 0,29 26 0,-8-15 0,75 45 0,-78-53 0,-3 0 0,0-2 0,2-2 0,0 0 0,1-3 0,0 0 0,40 9 0,37-4 0,30 8 0,-100-18 0,0-2 0,1-1 0,0-3 0,0-1 0,0-2 0,46-7 0,4-5 0,148-41 0,-227 49 0,-1 0 0,0-2 0,0 1 0,0-2 0,0 1 0,-1-2 0,-1 0 0,1 0 0,-1 0 0,0-2 0,-1 1 0,12-16 0,-13 18 0,-1 0 0,2 0 0,-1 1 0,1 1 0,0-1 0,13-5 0,-13 7 0,0-1 0,-1 0 0,1 0 0,14-13 0,-20 15 0,0-1 0,0 1 0,-1-1 0,1 0 0,-1 0 0,1 0 0,-1 0 0,-1 0 0,1 0 0,0 0 0,-1-1 0,0 1 0,0-1 0,0-7 0,0 1 0,0 0 0,-1 0 0,0-1 0,-1 1 0,0 0 0,-1 0 0,0 0 0,-7-19 0,0 10 0,0 1 0,-1 0 0,-20-27 0,-25-42 0,37 55 0,-2 2 0,-1 0 0,-2 1 0,-42-43 0,51 60 0,1 0 0,0 1 0,0 0 0,-1 1 0,-1 1 0,0 0 0,-1 1 0,1 0 0,-26-9 0,-37-4 58,-156-22-1,-88 11-1368,309 32 1142,-108-8-6657</inkml:trace>
+</inkml:ink>
+</file>
+
 <file path=ppt/ink/ink3.xml><?xml version="1.0" encoding="utf-8"?>
 <inkml:ink xmlns:inkml="http://www.w3.org/2003/InkML">
   <inkml:definitions>
@@ -1153,7 +1238,7 @@
           <a:p>
             <a:fld id="{CB233BD1-3BA8-448D-9D08-7846095EA517}" type="datetimeFigureOut">
               <a:rPr lang="en-US" smtClean="0"/>
-              <a:t>8/10/2026</a:t>
+              <a:t>8/20/2026</a:t>
             </a:fld>
             <a:endParaRPr lang="en-US"/>
           </a:p>
@@ -1567,7 +1652,7 @@
           <a:p>
             <a:fld id="{6383FAE1-13DE-4511-8C1B-C8AFB720664C}" type="datetimeFigureOut">
               <a:rPr lang="en-US" smtClean="0"/>
-              <a:t>8/10/2026</a:t>
+              <a:t>8/20/2026</a:t>
             </a:fld>
             <a:endParaRPr lang="en-US"/>
           </a:p>
@@ -1765,7 +1850,7 @@
           <a:p>
             <a:fld id="{6383FAE1-13DE-4511-8C1B-C8AFB720664C}" type="datetimeFigureOut">
               <a:rPr lang="en-US" smtClean="0"/>
-              <a:t>8/10/2026</a:t>
+              <a:t>8/20/2026</a:t>
             </a:fld>
             <a:endParaRPr lang="en-US"/>
           </a:p>
@@ -1973,7 +2058,7 @@
           <a:p>
             <a:fld id="{6383FAE1-13DE-4511-8C1B-C8AFB720664C}" type="datetimeFigureOut">
               <a:rPr lang="en-US" smtClean="0"/>
-              <a:t>8/10/2026</a:t>
+              <a:t>8/20/2026</a:t>
             </a:fld>
             <a:endParaRPr lang="en-US"/>
           </a:p>
@@ -2171,7 +2256,7 @@
           <a:p>
             <a:fld id="{6383FAE1-13DE-4511-8C1B-C8AFB720664C}" type="datetimeFigureOut">
               <a:rPr lang="en-US" smtClean="0"/>
-              <a:t>8/10/2026</a:t>
+              <a:t>8/20/2026</a:t>
             </a:fld>
             <a:endParaRPr lang="en-US"/>
           </a:p>
@@ -2446,7 +2531,7 @@
           <a:p>
             <a:fld id="{6383FAE1-13DE-4511-8C1B-C8AFB720664C}" type="datetimeFigureOut">
               <a:rPr lang="en-US" smtClean="0"/>
-              <a:t>8/10/2026</a:t>
+              <a:t>8/20/2026</a:t>
             </a:fld>
             <a:endParaRPr lang="en-US"/>
           </a:p>
@@ -2711,7 +2796,7 @@
           <a:p>
             <a:fld id="{6383FAE1-13DE-4511-8C1B-C8AFB720664C}" type="datetimeFigureOut">
               <a:rPr lang="en-US" smtClean="0"/>
-              <a:t>8/10/2026</a:t>
+              <a:t>8/20/2026</a:t>
             </a:fld>
             <a:endParaRPr lang="en-US"/>
           </a:p>
@@ -3123,7 +3208,7 @@
           <a:p>
             <a:fld id="{6383FAE1-13DE-4511-8C1B-C8AFB720664C}" type="datetimeFigureOut">
               <a:rPr lang="en-US" smtClean="0"/>
-              <a:t>8/10/2026</a:t>
+              <a:t>8/20/2026</a:t>
             </a:fld>
             <a:endParaRPr lang="en-US"/>
           </a:p>
@@ -3264,7 +3349,7 @@
           <a:p>
             <a:fld id="{6383FAE1-13DE-4511-8C1B-C8AFB720664C}" type="datetimeFigureOut">
               <a:rPr lang="en-US" smtClean="0"/>
-              <a:t>8/10/2026</a:t>
+              <a:t>8/20/2026</a:t>
             </a:fld>
             <a:endParaRPr lang="en-US"/>
           </a:p>
@@ -3377,7 +3462,7 @@
           <a:p>
             <a:fld id="{6383FAE1-13DE-4511-8C1B-C8AFB720664C}" type="datetimeFigureOut">
               <a:rPr lang="en-US" smtClean="0"/>
-              <a:t>8/10/2026</a:t>
+              <a:t>8/20/2026</a:t>
             </a:fld>
             <a:endParaRPr lang="en-US"/>
           </a:p>
@@ -3688,7 +3773,7 @@
           <a:p>
             <a:fld id="{6383FAE1-13DE-4511-8C1B-C8AFB720664C}" type="datetimeFigureOut">
               <a:rPr lang="en-US" smtClean="0"/>
-              <a:t>8/10/2026</a:t>
+              <a:t>8/20/2026</a:t>
             </a:fld>
             <a:endParaRPr lang="en-US"/>
           </a:p>
@@ -3979,7 +4064,7 @@
           <a:p>
             <a:fld id="{6383FAE1-13DE-4511-8C1B-C8AFB720664C}" type="datetimeFigureOut">
               <a:rPr lang="en-US" smtClean="0"/>
-              <a:t>8/10/2026</a:t>
+              <a:t>8/20/2026</a:t>
             </a:fld>
             <a:endParaRPr lang="en-US"/>
           </a:p>
@@ -4223,7 +4308,7 @@
           <a:p>
             <a:fld id="{6383FAE1-13DE-4511-8C1B-C8AFB720664C}" type="datetimeFigureOut">
               <a:rPr lang="en-US" smtClean="0"/>
-              <a:t>8/10/2026</a:t>
+              <a:t>8/20/2026</a:t>
             </a:fld>
             <a:endParaRPr lang="en-US"/>
           </a:p>
@@ -4848,6 +4933,267 @@
         <p:cNvPr id="1" name="">
           <a:extLst>
             <a:ext uri="{FF2B5EF4-FFF2-40B4-BE49-F238E27FC236}">
+              <a16:creationId xmlns:a16="http://schemas.microsoft.com/office/drawing/2014/main" id="{EF61F4F9-A9D0-048E-8F69-61272B7072D4}"/>
+            </a:ext>
+          </a:extLst>
+        </p:cNvPr>
+        <p:cNvGrpSpPr/>
+        <p:nvPr/>
+      </p:nvGrpSpPr>
+      <p:grpSpPr>
+        <a:xfrm>
+          <a:off x="0" y="0"/>
+          <a:ext cx="0" cy="0"/>
+          <a:chOff x="0" y="0"/>
+          <a:chExt cx="0" cy="0"/>
+        </a:xfrm>
+      </p:grpSpPr>
+      <p:sp>
+        <p:nvSpPr>
+          <p:cNvPr id="6" name="TextBox 5">
+            <a:extLst>
+              <a:ext uri="{FF2B5EF4-FFF2-40B4-BE49-F238E27FC236}">
+                <a16:creationId xmlns:a16="http://schemas.microsoft.com/office/drawing/2014/main" id="{95D2ADB4-BF77-3BDB-A0DF-F36CB1E13FD3}"/>
+              </a:ext>
+            </a:extLst>
+          </p:cNvPr>
+          <p:cNvSpPr txBox="1"/>
+          <p:nvPr/>
+        </p:nvSpPr>
+        <p:spPr>
+          <a:xfrm>
+            <a:off x="1306816" y="135342"/>
+            <a:ext cx="9782048" cy="830997"/>
+          </a:xfrm>
+          <a:prstGeom prst="rect">
+            <a:avLst/>
+          </a:prstGeom>
+          <a:noFill/>
+        </p:spPr>
+        <p:txBody>
+          <a:bodyPr wrap="square">
+            <a:spAutoFit/>
+          </a:bodyPr>
+          <a:lstStyle/>
+          <a:p>
+            <a:r>
+              <a:rPr lang="en-US" sz="2400" dirty="0">
+                <a:solidFill>
+                  <a:schemeClr val="accent6">
+                    <a:lumMod val="60000"/>
+                    <a:lumOff val="40000"/>
+                  </a:schemeClr>
+                </a:solidFill>
+              </a:rPr>
+              <a:t>Few Useful commands: Free up some space by  compacting/summarizing conversations</a:t>
+            </a:r>
+          </a:p>
+        </p:txBody>
+      </p:sp>
+      <p:pic>
+        <p:nvPicPr>
+          <p:cNvPr id="3" name="Picture 2">
+            <a:extLst>
+              <a:ext uri="{FF2B5EF4-FFF2-40B4-BE49-F238E27FC236}">
+                <a16:creationId xmlns:a16="http://schemas.microsoft.com/office/drawing/2014/main" id="{CC8D44E7-F9B5-3F43-C6C6-FDE486240063}"/>
+              </a:ext>
+            </a:extLst>
+          </p:cNvPr>
+          <p:cNvPicPr>
+            <a:picLocks noChangeAspect="1"/>
+          </p:cNvPicPr>
+          <p:nvPr/>
+        </p:nvPicPr>
+        <p:blipFill>
+          <a:blip r:embed="rId2"/>
+          <a:stretch>
+            <a:fillRect/>
+          </a:stretch>
+        </p:blipFill>
+        <p:spPr>
+          <a:xfrm>
+            <a:off x="3323253" y="1636425"/>
+            <a:ext cx="8459381" cy="5029902"/>
+          </a:xfrm>
+          <a:prstGeom prst="rect">
+            <a:avLst/>
+          </a:prstGeom>
+        </p:spPr>
+      </p:pic>
+      <mc:AlternateContent xmlns:mc="http://schemas.openxmlformats.org/markup-compatibility/2006">
+        <mc:Choice xmlns:p14="http://schemas.microsoft.com/office/powerpoint/2010/main" Requires="p14">
+          <p:contentPart p14:bwMode="auto" r:id="rId3">
+            <p14:nvContentPartPr>
+              <p14:cNvPr id="4" name="Ink 3">
+                <a:extLst>
+                  <a:ext uri="{FF2B5EF4-FFF2-40B4-BE49-F238E27FC236}">
+                    <a16:creationId xmlns:a16="http://schemas.microsoft.com/office/drawing/2014/main" id="{80AE63A0-BC80-47F4-C297-97E619C6787B}"/>
+                  </a:ext>
+                </a:extLst>
+              </p14:cNvPr>
+              <p14:cNvContentPartPr/>
+              <p14:nvPr/>
+            </p14:nvContentPartPr>
+            <p14:xfrm>
+              <a:off x="10643544" y="5870376"/>
+              <a:ext cx="445320" cy="354600"/>
+            </p14:xfrm>
+          </p:contentPart>
+        </mc:Choice>
+        <mc:Fallback>
+          <p:pic>
+            <p:nvPicPr>
+              <p:cNvPr id="4" name="Ink 3">
+                <a:extLst>
+                  <a:ext uri="{FF2B5EF4-FFF2-40B4-BE49-F238E27FC236}">
+                    <a16:creationId xmlns:a16="http://schemas.microsoft.com/office/drawing/2014/main" id="{80AE63A0-BC80-47F4-C297-97E619C6787B}"/>
+                  </a:ext>
+                </a:extLst>
+              </p:cNvPr>
+              <p:cNvPicPr/>
+              <p:nvPr/>
+            </p:nvPicPr>
+            <p:blipFill>
+              <a:blip r:embed="rId4"/>
+              <a:stretch>
+                <a:fillRect/>
+              </a:stretch>
+            </p:blipFill>
+            <p:spPr>
+              <a:xfrm>
+                <a:off x="10625904" y="5852376"/>
+                <a:ext cx="480960" cy="390240"/>
+              </a:xfrm>
+              <a:prstGeom prst="rect">
+                <a:avLst/>
+              </a:prstGeom>
+            </p:spPr>
+          </p:pic>
+        </mc:Fallback>
+      </mc:AlternateContent>
+      <mc:AlternateContent xmlns:mc="http://schemas.openxmlformats.org/markup-compatibility/2006">
+        <mc:Choice xmlns:p14="http://schemas.microsoft.com/office/powerpoint/2010/main" Requires="p14">
+          <p:contentPart p14:bwMode="auto" r:id="rId5">
+            <p14:nvContentPartPr>
+              <p14:cNvPr id="7" name="Ink 6">
+                <a:extLst>
+                  <a:ext uri="{FF2B5EF4-FFF2-40B4-BE49-F238E27FC236}">
+                    <a16:creationId xmlns:a16="http://schemas.microsoft.com/office/drawing/2014/main" id="{652BF585-D433-B177-7BBE-1066385D976C}"/>
+                  </a:ext>
+                </a:extLst>
+              </p14:cNvPr>
+              <p14:cNvContentPartPr/>
+              <p14:nvPr/>
+            </p14:nvContentPartPr>
+            <p14:xfrm>
+              <a:off x="4608504" y="2667816"/>
+              <a:ext cx="582480" cy="311760"/>
+            </p14:xfrm>
+          </p:contentPart>
+        </mc:Choice>
+        <mc:Fallback>
+          <p:pic>
+            <p:nvPicPr>
+              <p:cNvPr id="7" name="Ink 6">
+                <a:extLst>
+                  <a:ext uri="{FF2B5EF4-FFF2-40B4-BE49-F238E27FC236}">
+                    <a16:creationId xmlns:a16="http://schemas.microsoft.com/office/drawing/2014/main" id="{652BF585-D433-B177-7BBE-1066385D976C}"/>
+                  </a:ext>
+                </a:extLst>
+              </p:cNvPr>
+              <p:cNvPicPr/>
+              <p:nvPr/>
+            </p:nvPicPr>
+            <p:blipFill>
+              <a:blip r:embed="rId6"/>
+              <a:stretch>
+                <a:fillRect/>
+              </a:stretch>
+            </p:blipFill>
+            <p:spPr>
+              <a:xfrm>
+                <a:off x="4590504" y="2650176"/>
+                <a:ext cx="618120" cy="347400"/>
+              </a:xfrm>
+              <a:prstGeom prst="rect">
+                <a:avLst/>
+              </a:prstGeom>
+            </p:spPr>
+          </p:pic>
+        </mc:Fallback>
+      </mc:AlternateContent>
+      <mc:AlternateContent xmlns:mc="http://schemas.openxmlformats.org/markup-compatibility/2006">
+        <mc:Choice xmlns:p14="http://schemas.microsoft.com/office/powerpoint/2010/main" Requires="p14">
+          <p:contentPart p14:bwMode="auto" r:id="rId7">
+            <p14:nvContentPartPr>
+              <p14:cNvPr id="8" name="Ink 7">
+                <a:extLst>
+                  <a:ext uri="{FF2B5EF4-FFF2-40B4-BE49-F238E27FC236}">
+                    <a16:creationId xmlns:a16="http://schemas.microsoft.com/office/drawing/2014/main" id="{4AA36F30-6802-41B8-8089-03E79E8A8633}"/>
+                  </a:ext>
+                </a:extLst>
+              </p14:cNvPr>
+              <p14:cNvContentPartPr/>
+              <p14:nvPr/>
+            </p14:nvContentPartPr>
+            <p14:xfrm>
+              <a:off x="3730824" y="5760576"/>
+              <a:ext cx="660240" cy="385920"/>
+            </p14:xfrm>
+          </p:contentPart>
+        </mc:Choice>
+        <mc:Fallback>
+          <p:pic>
+            <p:nvPicPr>
+              <p:cNvPr id="8" name="Ink 7">
+                <a:extLst>
+                  <a:ext uri="{FF2B5EF4-FFF2-40B4-BE49-F238E27FC236}">
+                    <a16:creationId xmlns:a16="http://schemas.microsoft.com/office/drawing/2014/main" id="{4AA36F30-6802-41B8-8089-03E79E8A8633}"/>
+                  </a:ext>
+                </a:extLst>
+              </p:cNvPr>
+              <p:cNvPicPr/>
+              <p:nvPr/>
+            </p:nvPicPr>
+            <p:blipFill>
+              <a:blip r:embed="rId8"/>
+              <a:stretch>
+                <a:fillRect/>
+              </a:stretch>
+            </p:blipFill>
+            <p:spPr>
+              <a:xfrm>
+                <a:off x="3713184" y="5742936"/>
+                <a:ext cx="695880" cy="421560"/>
+              </a:xfrm>
+              <a:prstGeom prst="rect">
+                <a:avLst/>
+              </a:prstGeom>
+            </p:spPr>
+          </p:pic>
+        </mc:Fallback>
+      </mc:AlternateContent>
+    </p:spTree>
+    <p:extLst>
+      <p:ext uri="{BB962C8B-B14F-4D97-AF65-F5344CB8AC3E}">
+        <p14:creationId xmlns:p14="http://schemas.microsoft.com/office/powerpoint/2010/main" val="1862951942"/>
+      </p:ext>
+    </p:extLst>
+  </p:cSld>
+  <p:clrMapOvr>
+    <a:masterClrMapping/>
+  </p:clrMapOvr>
+</p:sld>
+</file>
+
+<file path=ppt/slides/slide11.xml><?xml version="1.0" encoding="utf-8"?>
+<p:sld xmlns:a="http://schemas.openxmlformats.org/drawingml/2006/main" xmlns:r="http://schemas.openxmlformats.org/officeDocument/2006/relationships" xmlns:p="http://schemas.openxmlformats.org/presentationml/2006/main">
+  <p:cSld>
+    <p:spTree>
+      <p:nvGrpSpPr>
+        <p:cNvPr id="1" name="">
+          <a:extLst>
+            <a:ext uri="{FF2B5EF4-FFF2-40B4-BE49-F238E27FC236}">
               <a16:creationId xmlns:a16="http://schemas.microsoft.com/office/drawing/2014/main" id="{DD931D7F-4279-DA2E-FA64-6CF3C441D414}"/>
             </a:ext>
           </a:extLst>
@@ -7271,7 +7617,7 @@
           <a:lstStyle/>
           <a:p>
             <a:r>
-              <a:rPr lang="en-US" sz="2400">
+              <a:rPr lang="en-US" sz="2400" dirty="0">
                 <a:solidFill>
                   <a:schemeClr val="accent6">
                     <a:lumMod val="60000"/>
@@ -7281,14 +7627,6 @@
               </a:rPr>
               <a:t>You are good to go</a:t>
             </a:r>
-            <a:endParaRPr lang="en-US" sz="2400" dirty="0">
-              <a:solidFill>
-                <a:schemeClr val="accent6">
-                  <a:lumMod val="60000"/>
-                  <a:lumOff val="40000"/>
-                </a:schemeClr>
-              </a:solidFill>
-            </a:endParaRPr>
           </a:p>
         </p:txBody>
       </p:sp>

</xml_diff>